<commit_message>
Update investor pitch presentation
</commit_message>
<xml_diff>
--- a/Hub/investors presentation/KungFlow Investor Pitch - Updated.pptx
+++ b/Hub/investors presentation/KungFlow Investor Pitch - Updated.pptx
@@ -16,6 +16,7 @@
     <p:sldId id="261" r:id="rId7"/>
     <p:sldId id="262" r:id="rId8"/>
     <p:sldId id="272" r:id="rId24"/>
+    <p:sldId id="273" r:id="rId25"/>
     <p:sldId id="263" r:id="rId9"/>
     <p:sldId id="264" r:id="rId10"/>
     <p:sldId id="265" r:id="rId11"/>
@@ -3163,7 +3164,7 @@
                 <a:ea typeface="Calibri" pitchFamily="34" charset="-122"/>
                 <a:cs typeface="Calibri" pitchFamily="34" charset="-120"/>
               </a:rPr>
-              <a:t>11</a:t>
+              <a:t>12</a:t>
             </a:r>
             <a:endParaRPr lang="en-US" sz="1200" dirty="0"/>
           </a:p>
@@ -4147,7 +4148,7 @@
                 <a:ea typeface="Calibri" pitchFamily="34" charset="-122"/>
                 <a:cs typeface="Calibri" pitchFamily="34" charset="-120"/>
               </a:rPr>
-              <a:t>12</a:t>
+              <a:t>13</a:t>
             </a:r>
             <a:endParaRPr lang="en-US" sz="1200" dirty="0"/>
           </a:p>
@@ -5616,7 +5617,7 @@
                 <a:ea typeface="Calibri" pitchFamily="34" charset="-122"/>
                 <a:cs typeface="Calibri" pitchFamily="34" charset="-120"/>
               </a:rPr>
-              <a:t>13</a:t>
+              <a:t>14</a:t>
             </a:r>
             <a:endParaRPr lang="en-US" sz="1200" dirty="0"/>
           </a:p>
@@ -7284,7 +7285,7 @@
                 <a:ea typeface="Calibri" pitchFamily="34" charset="-122"/>
                 <a:cs typeface="Calibri" pitchFamily="34" charset="-120"/>
               </a:rPr>
-              <a:t>14</a:t>
+              <a:t>15</a:t>
             </a:r>
             <a:endParaRPr lang="en-US" sz="1200" dirty="0"/>
           </a:p>
@@ -8897,7 +8898,7 @@
                 </a:solidFill>
                 <a:latin typeface="Calibri"/>
               </a:rPr>
-              <a:t>15</a:t>
+              <a:t>16</a:t>
             </a:r>
           </a:p>
         </p:txBody>
@@ -9779,7 +9780,7 @@
                 </a:solidFill>
                 <a:latin typeface="Calibri"/>
               </a:rPr>
-              <a:t>16</a:t>
+              <a:t>17</a:t>
             </a:r>
           </a:p>
         </p:txBody>
@@ -11571,6 +11572,1820 @@
 </p:sld>
 </file>
 
+<file path=ppt/slides/slide18.xml><?xml version="1.0" encoding="utf-8"?>
+<p:sld xmlns:a="http://schemas.openxmlformats.org/drawingml/2006/main" xmlns:r="http://schemas.openxmlformats.org/officeDocument/2006/relationships" xmlns:p="http://schemas.openxmlformats.org/presentationml/2006/main">
+  <p:cSld name="Slide 9">
+    <p:bg>
+      <p:bgPr>
+        <a:solidFill>
+          <a:srgbClr val="F8F7F3"/>
+        </a:solidFill>
+        <a:effectLst/>
+      </p:bgPr>
+    </p:bg>
+    <p:spTree>
+      <p:nvGrpSpPr>
+        <p:cNvPr id="1" name=""/>
+        <p:cNvGrpSpPr/>
+        <p:nvPr/>
+      </p:nvGrpSpPr>
+      <p:grpSpPr>
+        <a:xfrm>
+          <a:off x="0" y="0"/>
+          <a:ext cx="0" cy="0"/>
+          <a:chOff x="0" y="0"/>
+          <a:chExt cx="0" cy="0"/>
+        </a:xfrm>
+      </p:grpSpPr>
+      <p:sp>
+        <p:nvSpPr>
+          <p:cNvPr id="2" name="Header dot"/>
+          <p:cNvSpPr/>
+          <p:nvPr/>
+        </p:nvSpPr>
+        <p:spPr>
+          <a:xfrm>
+            <a:off x="594360" y="429768"/>
+            <a:ext cx="146304" cy="146304"/>
+          </a:xfrm>
+          <a:prstGeom prst="ellipse">
+            <a:avLst/>
+          </a:prstGeom>
+          <a:solidFill>
+            <a:srgbClr val="0E8F84"/>
+          </a:solidFill>
+          <a:ln>
+            <a:noFill/>
+          </a:ln>
+        </p:spPr>
+        <p:txBody>
+          <a:bodyPr/>
+          <a:lstStyle/>
+          <a:p>
+            <a:endParaRPr lang="en-US"/>
+          </a:p>
+        </p:txBody>
+      </p:sp>
+      <p:sp>
+        <p:nvSpPr>
+          <p:cNvPr id="3" name="Eyebrow"/>
+          <p:cNvSpPr/>
+          <p:nvPr/>
+        </p:nvSpPr>
+        <p:spPr>
+          <a:xfrm>
+            <a:off x="813816" y="283464"/>
+            <a:ext cx="6400800" cy="411480"/>
+          </a:xfrm>
+          <a:prstGeom prst="rect">
+            <a:avLst/>
+          </a:prstGeom>
+          <a:noFill/>
+          <a:ln>
+            <a:noFill/>
+          </a:ln>
+        </p:spPr>
+        <p:txBody>
+          <a:bodyPr wrap="square" lIns="0" tIns="0" rIns="0" bIns="0" rtlCol="0" anchor="ctr"/>
+          <a:lstStyle/>
+          <a:p>
+            <a:pPr marL="0" indent="0" algn="l">
+              <a:buNone/>
+            </a:pPr>
+            <a:r>
+              <a:rPr lang="en-US" sz="1400" b="1" kern="0" spc="300" dirty="0">
+                <a:solidFill>
+                  <a:srgbClr val="0B6E66"/>
+                </a:solidFill>
+                <a:latin typeface="Trebuchet MS" pitchFamily="34" charset="0"/>
+                <a:ea typeface="Trebuchet MS" pitchFamily="34" charset="-122"/>
+                <a:cs typeface="Trebuchet MS" pitchFamily="34" charset="-120"/>
+              </a:rPr>
+              <a:t>ARCHITECTURE</a:t>
+            </a:r>
+            <a:endParaRPr lang="en-US" sz="1400" dirty="0"/>
+          </a:p>
+        </p:txBody>
+      </p:sp>
+      <p:sp>
+        <p:nvSpPr>
+          <p:cNvPr id="4" name="Title"/>
+          <p:cNvSpPr/>
+          <p:nvPr/>
+        </p:nvSpPr>
+        <p:spPr>
+          <a:xfrm>
+            <a:off x="594360" y="658368"/>
+            <a:ext cx="9906000" cy="868680"/>
+          </a:xfrm>
+          <a:prstGeom prst="rect">
+            <a:avLst/>
+          </a:prstGeom>
+          <a:noFill/>
+          <a:ln>
+            <a:noFill/>
+          </a:ln>
+        </p:spPr>
+        <p:txBody>
+          <a:bodyPr wrap="square" lIns="0" tIns="0" rIns="0" bIns="0" rtlCol="0" anchor="ctr"/>
+          <a:lstStyle/>
+          <a:p>
+            <a:pPr marL="0" indent="0" algn="l">
+              <a:buNone/>
+            </a:pPr>
+            <a:r>
+              <a:rPr lang="en-US" sz="3000" b="1" kern="0" dirty="0">
+                <a:solidFill>
+                  <a:srgbClr val="122033"/>
+                </a:solidFill>
+                <a:latin typeface="Trebuchet MS" pitchFamily="34" charset="0"/>
+                <a:ea typeface="Trebuchet MS" pitchFamily="34" charset="-122"/>
+                <a:cs typeface="Trebuchet MS" pitchFamily="34" charset="-120"/>
+              </a:rPr>
+              <a:t>How did we build it?</a:t>
+            </a:r>
+            <a:endParaRPr lang="en-US" sz="3000" dirty="0"/>
+          </a:p>
+        </p:txBody>
+      </p:sp>
+      <p:sp>
+        <p:nvSpPr>
+          <p:cNvPr id="5" name="Page number"/>
+          <p:cNvSpPr/>
+          <p:nvPr/>
+        </p:nvSpPr>
+        <p:spPr>
+          <a:xfrm>
+            <a:off x="11274552" y="6355080"/>
+            <a:ext cx="457200" cy="320040"/>
+          </a:xfrm>
+          <a:prstGeom prst="rect">
+            <a:avLst/>
+          </a:prstGeom>
+          <a:noFill/>
+          <a:ln>
+            <a:noFill/>
+          </a:ln>
+        </p:spPr>
+        <p:txBody>
+          <a:bodyPr wrap="square" lIns="0" tIns="0" rIns="0" bIns="0" rtlCol="0" anchor="ctr"/>
+          <a:lstStyle/>
+          <a:p>
+            <a:pPr marL="0" indent="0" algn="r">
+              <a:buNone/>
+            </a:pPr>
+            <a:r>
+              <a:rPr lang="en-US" sz="1600" b="1" kern="0" dirty="0">
+                <a:solidFill>
+                  <a:srgbClr val="7A8A9C"/>
+                </a:solidFill>
+                <a:latin typeface="Trebuchet MS" pitchFamily="34" charset="0"/>
+                <a:ea typeface="Trebuchet MS" pitchFamily="34" charset="-122"/>
+                <a:cs typeface="Trebuchet MS" pitchFamily="34" charset="-120"/>
+              </a:rPr>
+              <a:t>9</a:t>
+            </a:r>
+            <a:endParaRPr lang="en-US" sz="1600" dirty="0"/>
+          </a:p>
+        </p:txBody>
+      </p:sp>
+      <p:sp>
+        <p:nvSpPr>
+          <p:cNvPr id="6" name="Logo card"/>
+          <p:cNvSpPr/>
+          <p:nvPr/>
+        </p:nvSpPr>
+        <p:spPr>
+          <a:xfrm>
+            <a:off x="11109960" y="237744"/>
+            <a:ext cx="585216" cy="548640"/>
+          </a:xfrm>
+          <a:prstGeom prst="roundRect">
+            <a:avLst/>
+          </a:prstGeom>
+          <a:solidFill>
+            <a:srgbClr val="FFFFFF"/>
+          </a:solidFill>
+          <a:ln w="9525">
+            <a:solidFill>
+              <a:srgbClr val="E4EBEA"/>
+            </a:solidFill>
+          </a:ln>
+        </p:spPr>
+        <p:txBody>
+          <a:bodyPr/>
+          <a:lstStyle/>
+          <a:p>
+            <a:endParaRPr lang="en-US"/>
+          </a:p>
+        </p:txBody>
+      </p:sp>
+      <p:pic>
+        <p:nvPicPr>
+          <p:cNvPr id="7" name="KungFlow logo"/>
+          <p:cNvPicPr>
+            <a:picLocks noChangeAspect="1"/>
+          </p:cNvPicPr>
+          <p:nvPr/>
+        </p:nvPicPr>
+        <p:blipFill>
+          <a:blip r:embed="rId3"/>
+          <a:stretch>
+            <a:fillRect/>
+          </a:stretch>
+        </p:blipFill>
+        <p:spPr>
+          <a:xfrm>
+            <a:off x="11155680" y="283464"/>
+            <a:ext cx="493776" cy="457200"/>
+          </a:xfrm>
+          <a:prstGeom prst="rect">
+            <a:avLst/>
+          </a:prstGeom>
+          <a:ln>
+            <a:noFill/>
+          </a:ln>
+        </p:spPr>
+      </p:pic>
+      <p:sp>
+        <p:nvSpPr>
+          <p:cNvPr id="8" name="Architecture subtitle"/>
+          <p:cNvSpPr/>
+          <p:nvPr/>
+        </p:nvSpPr>
+        <p:spPr>
+          <a:xfrm>
+            <a:off x="1524000" y="1323975"/>
+            <a:ext cx="9144000" cy="419100"/>
+          </a:xfrm>
+          <a:prstGeom prst="rect">
+            <a:avLst/>
+          </a:prstGeom>
+          <a:noFill/>
+          <a:ln>
+            <a:noFill/>
+          </a:ln>
+        </p:spPr>
+        <p:txBody>
+          <a:bodyPr wrap="square" lIns="0" tIns="0" rIns="0" bIns="0" rtlCol="0" anchor="ctr"/>
+          <a:lstStyle/>
+          <a:p>
+            <a:pPr marL="0" indent="0" algn="ctr">
+              <a:buNone/>
+            </a:pPr>
+            <a:r>
+              <a:rPr lang="en-US" sz="1700" kern="0" dirty="0">
+                <a:solidFill>
+                  <a:srgbClr val="58677A"/>
+                </a:solidFill>
+                <a:latin typeface="Trebuchet MS" pitchFamily="34" charset="0"/>
+                <a:ea typeface="Trebuchet MS" pitchFamily="34" charset="-122"/>
+                <a:cs typeface="Trebuchet MS" pitchFamily="34" charset="-120"/>
+              </a:rPr>
+              <a:t>A lightweight client-server loop connects the Windows agent, the scoring backend, and SQL storage.</a:t>
+            </a:r>
+            <a:endParaRPr lang="en-US" sz="1700" dirty="0"/>
+          </a:p>
+        </p:txBody>
+      </p:sp>
+      <p:sp>
+        <p:nvSpPr>
+          <p:cNvPr id="9" name="Activity sample arrow"/>
+          <p:cNvSpPr/>
+          <p:nvPr/>
+        </p:nvSpPr>
+        <p:spPr>
+          <a:xfrm>
+            <a:off x="3552825" y="3314700"/>
+            <a:ext cx="1019175" cy="295275"/>
+          </a:xfrm>
+          <a:prstGeom prst="rightArrow">
+            <a:avLst/>
+          </a:prstGeom>
+          <a:solidFill>
+            <a:srgbClr val="0E8F84"/>
+          </a:solidFill>
+          <a:ln>
+            <a:noFill/>
+          </a:ln>
+        </p:spPr>
+        <p:txBody>
+          <a:bodyPr/>
+          <a:lstStyle/>
+          <a:p>
+            <a:endParaRPr lang="en-US"/>
+          </a:p>
+        </p:txBody>
+      </p:sp>
+      <p:sp>
+        <p:nvSpPr>
+          <p:cNvPr id="10" name="Activity sample label"/>
+          <p:cNvSpPr/>
+          <p:nvPr/>
+        </p:nvSpPr>
+        <p:spPr>
+          <a:xfrm>
+            <a:off x="3505200" y="3638550"/>
+            <a:ext cx="1104900" cy="228600"/>
+          </a:xfrm>
+          <a:prstGeom prst="rect">
+            <a:avLst/>
+          </a:prstGeom>
+          <a:noFill/>
+          <a:ln>
+            <a:noFill/>
+          </a:ln>
+        </p:spPr>
+        <p:txBody>
+          <a:bodyPr wrap="square" lIns="0" tIns="0" rIns="0" bIns="0" rtlCol="0" anchor="ctr"/>
+          <a:lstStyle/>
+          <a:p>
+            <a:pPr marL="0" indent="0" algn="ctr">
+              <a:buNone/>
+            </a:pPr>
+            <a:r>
+              <a:rPr lang="en-US" sz="850" b="1" kern="0" spc="80" dirty="0">
+                <a:solidFill>
+                  <a:srgbClr val="0E8F84"/>
+                </a:solidFill>
+                <a:latin typeface="Trebuchet MS" pitchFamily="34" charset="0"/>
+                <a:ea typeface="Trebuchet MS" pitchFamily="34" charset="-122"/>
+                <a:cs typeface="Trebuchet MS" pitchFamily="34" charset="-120"/>
+              </a:rPr>
+              <a:t>ACTIVITY SAMPLE</a:t>
+            </a:r>
+            <a:endParaRPr lang="en-US" sz="850" dirty="0"/>
+          </a:p>
+        </p:txBody>
+      </p:sp>
+      <p:sp>
+        <p:nvSpPr>
+          <p:cNvPr id="11" name="Protection decision arrow"/>
+          <p:cNvSpPr/>
+          <p:nvPr/>
+        </p:nvSpPr>
+        <p:spPr>
+          <a:xfrm>
+            <a:off x="3552825" y="2571750"/>
+            <a:ext cx="1019175" cy="247650"/>
+          </a:xfrm>
+          <a:prstGeom prst="leftArrow">
+            <a:avLst/>
+          </a:prstGeom>
+          <a:solidFill>
+            <a:srgbClr val="3478E5"/>
+          </a:solidFill>
+          <a:ln>
+            <a:noFill/>
+          </a:ln>
+        </p:spPr>
+        <p:txBody>
+          <a:bodyPr/>
+          <a:lstStyle/>
+          <a:p>
+            <a:endParaRPr lang="en-US"/>
+          </a:p>
+        </p:txBody>
+      </p:sp>
+      <p:sp>
+        <p:nvSpPr>
+          <p:cNvPr id="12" name="Protection decision label"/>
+          <p:cNvSpPr/>
+          <p:nvPr/>
+        </p:nvSpPr>
+        <p:spPr>
+          <a:xfrm>
+            <a:off x="3448050" y="2324100"/>
+            <a:ext cx="1219200" cy="228600"/>
+          </a:xfrm>
+          <a:prstGeom prst="rect">
+            <a:avLst/>
+          </a:prstGeom>
+          <a:noFill/>
+          <a:ln>
+            <a:noFill/>
+          </a:ln>
+        </p:spPr>
+        <p:txBody>
+          <a:bodyPr wrap="square" lIns="0" tIns="0" rIns="0" bIns="0" rtlCol="0" anchor="ctr"/>
+          <a:lstStyle/>
+          <a:p>
+            <a:pPr marL="0" indent="0" algn="ctr">
+              <a:buNone/>
+            </a:pPr>
+            <a:r>
+              <a:rPr lang="en-US" sz="820" b="1" kern="0" spc="60" dirty="0">
+                <a:solidFill>
+                  <a:srgbClr val="3478E5"/>
+                </a:solidFill>
+                <a:latin typeface="Trebuchet MS" pitchFamily="34" charset="0"/>
+                <a:ea typeface="Trebuchet MS" pitchFamily="34" charset="-122"/>
+                <a:cs typeface="Trebuchet MS" pitchFamily="34" charset="-120"/>
+              </a:rPr>
+              <a:t>PROTECTION DECISION</a:t>
+            </a:r>
+            <a:endParaRPr lang="en-US" sz="820" dirty="0"/>
+          </a:p>
+        </p:txBody>
+      </p:sp>
+      <p:sp>
+        <p:nvSpPr>
+          <p:cNvPr id="13" name="Database sync arrow"/>
+          <p:cNvSpPr/>
+          <p:nvPr/>
+        </p:nvSpPr>
+        <p:spPr>
+          <a:xfrm>
+            <a:off x="7620000" y="3314700"/>
+            <a:ext cx="1019175" cy="295275"/>
+          </a:xfrm>
+          <a:prstGeom prst="leftRightArrow">
+            <a:avLst/>
+          </a:prstGeom>
+          <a:solidFill>
+            <a:srgbClr val="7B61D1"/>
+          </a:solidFill>
+          <a:ln>
+            <a:noFill/>
+          </a:ln>
+        </p:spPr>
+        <p:txBody>
+          <a:bodyPr/>
+          <a:lstStyle/>
+          <a:p>
+            <a:endParaRPr lang="en-US"/>
+          </a:p>
+        </p:txBody>
+      </p:sp>
+      <p:sp>
+        <p:nvSpPr>
+          <p:cNvPr id="14" name="Database sync label"/>
+          <p:cNvSpPr/>
+          <p:nvPr/>
+        </p:nvSpPr>
+        <p:spPr>
+          <a:xfrm>
+            <a:off x="7572375" y="3638550"/>
+            <a:ext cx="1104900" cy="228600"/>
+          </a:xfrm>
+          <a:prstGeom prst="rect">
+            <a:avLst/>
+          </a:prstGeom>
+          <a:noFill/>
+          <a:ln>
+            <a:noFill/>
+          </a:ln>
+        </p:spPr>
+        <p:txBody>
+          <a:bodyPr wrap="square" lIns="0" tIns="0" rIns="0" bIns="0" rtlCol="0" anchor="ctr"/>
+          <a:lstStyle/>
+          <a:p>
+            <a:pPr marL="0" indent="0" algn="ctr">
+              <a:buNone/>
+            </a:pPr>
+            <a:r>
+              <a:rPr lang="en-US" sz="820" b="1" kern="0" spc="50" dirty="0">
+                <a:solidFill>
+                  <a:srgbClr val="7B61D1"/>
+                </a:solidFill>
+                <a:latin typeface="Trebuchet MS" pitchFamily="34" charset="0"/>
+                <a:ea typeface="Trebuchet MS" pitchFamily="34" charset="-122"/>
+                <a:cs typeface="Trebuchet MS" pitchFamily="34" charset="-120"/>
+              </a:rPr>
+              <a:t>METRICS + BASELINE</a:t>
+            </a:r>
+            <a:endParaRPr lang="en-US" sz="820" dirty="0"/>
+          </a:p>
+        </p:txBody>
+      </p:sp>
+      <p:sp>
+        <p:nvSpPr>
+          <p:cNvPr id="15" name="Desktop Agent card"/>
+          <p:cNvSpPr/>
+          <p:nvPr/>
+        </p:nvSpPr>
+        <p:spPr>
+          <a:xfrm>
+            <a:off x="594360" y="2047875"/>
+            <a:ext cx="2857500" cy="3000375"/>
+          </a:xfrm>
+          <a:prstGeom prst="roundRect">
+            <a:avLst/>
+          </a:prstGeom>
+          <a:solidFill>
+            <a:srgbClr val="FFFFFF"/>
+          </a:solidFill>
+          <a:ln w="9525">
+            <a:solidFill>
+              <a:srgbClr val="D7E2E0"/>
+            </a:solidFill>
+          </a:ln>
+        </p:spPr>
+        <p:txBody>
+          <a:bodyPr/>
+          <a:lstStyle/>
+          <a:p>
+            <a:endParaRPr lang="en-US"/>
+          </a:p>
+        </p:txBody>
+      </p:sp>
+      <p:sp>
+        <p:nvSpPr>
+          <p:cNvPr id="16" name="Desktop Agent icon box"/>
+          <p:cNvSpPr/>
+          <p:nvPr/>
+        </p:nvSpPr>
+        <p:spPr>
+          <a:xfrm>
+            <a:off x="861060" y="2343150"/>
+            <a:ext cx="685800" cy="685800"/>
+          </a:xfrm>
+          <a:prstGeom prst="roundRect">
+            <a:avLst/>
+          </a:prstGeom>
+          <a:solidFill>
+            <a:srgbClr val="EDF4F3"/>
+          </a:solidFill>
+          <a:ln w="9525">
+            <a:solidFill>
+              <a:srgbClr val="CFE0DD"/>
+            </a:solidFill>
+          </a:ln>
+        </p:spPr>
+        <p:txBody>
+          <a:bodyPr/>
+          <a:lstStyle/>
+          <a:p>
+            <a:endParaRPr lang="en-US"/>
+          </a:p>
+        </p:txBody>
+      </p:sp>
+      <p:pic>
+        <p:nvPicPr>
+          <p:cNvPr id="17" name="Desktop Agent icon"/>
+          <p:cNvPicPr>
+            <a:picLocks noChangeAspect="1"/>
+          </p:cNvPicPr>
+          <p:nvPr/>
+        </p:nvPicPr>
+        <p:blipFill>
+          <a:blip r:embed="rId4"/>
+          <a:stretch>
+            <a:fillRect/>
+          </a:stretch>
+        </p:blipFill>
+        <p:spPr>
+          <a:xfrm>
+            <a:off x="1022985" y="2505075"/>
+            <a:ext cx="361950" cy="361950"/>
+          </a:xfrm>
+          <a:prstGeom prst="rect">
+            <a:avLst/>
+          </a:prstGeom>
+          <a:ln>
+            <a:noFill/>
+          </a:ln>
+        </p:spPr>
+      </p:pic>
+      <p:sp>
+        <p:nvSpPr>
+          <p:cNvPr id="18" name="Desktop Agent title"/>
+          <p:cNvSpPr/>
+          <p:nvPr/>
+        </p:nvSpPr>
+        <p:spPr>
+          <a:xfrm>
+            <a:off x="1623060" y="2409825"/>
+            <a:ext cx="1581150" cy="419100"/>
+          </a:xfrm>
+          <a:prstGeom prst="rect">
+            <a:avLst/>
+          </a:prstGeom>
+          <a:noFill/>
+          <a:ln>
+            <a:noFill/>
+          </a:ln>
+        </p:spPr>
+        <p:txBody>
+          <a:bodyPr wrap="square" lIns="0" tIns="0" rIns="0" bIns="0" rtlCol="0" anchor="ctr"/>
+          <a:lstStyle/>
+          <a:p>
+            <a:pPr marL="0" indent="0" algn="l">
+              <a:buNone/>
+            </a:pPr>
+            <a:r>
+              <a:rPr lang="en-US" sz="1850" b="1" kern="0" dirty="0">
+                <a:solidFill>
+                  <a:srgbClr val="122033"/>
+                </a:solidFill>
+                <a:latin typeface="Trebuchet MS" pitchFamily="34" charset="0"/>
+                <a:ea typeface="Trebuchet MS" pitchFamily="34" charset="-122"/>
+                <a:cs typeface="Trebuchet MS" pitchFamily="34" charset="-120"/>
+              </a:rPr>
+              <a:t>Desktop Agent</a:t>
+            </a:r>
+            <a:endParaRPr lang="en-US" sz="1850" dirty="0"/>
+          </a:p>
+        </p:txBody>
+      </p:sp>
+      <p:sp>
+        <p:nvSpPr>
+          <p:cNvPr id="19" name="Desktop Agent accent"/>
+          <p:cNvSpPr/>
+          <p:nvPr/>
+        </p:nvSpPr>
+        <p:spPr>
+          <a:xfrm>
+            <a:off x="594360" y="2047875"/>
+            <a:ext cx="2857500" cy="66675"/>
+          </a:xfrm>
+          <a:prstGeom prst="rect">
+            <a:avLst/>
+          </a:prstGeom>
+          <a:solidFill>
+            <a:srgbClr val="0E8F84"/>
+          </a:solidFill>
+          <a:ln>
+            <a:noFill/>
+          </a:ln>
+        </p:spPr>
+        <p:txBody>
+          <a:bodyPr/>
+          <a:lstStyle/>
+          <a:p>
+            <a:endParaRPr lang="en-US"/>
+          </a:p>
+        </p:txBody>
+      </p:sp>
+      <p:sp>
+        <p:nvSpPr>
+          <p:cNvPr id="20" name="Desktop Agent body"/>
+          <p:cNvSpPr/>
+          <p:nvPr/>
+        </p:nvSpPr>
+        <p:spPr>
+          <a:xfrm>
+            <a:off x="861060" y="3267075"/>
+            <a:ext cx="2324100" cy="1000125"/>
+          </a:xfrm>
+          <a:prstGeom prst="rect">
+            <a:avLst/>
+          </a:prstGeom>
+          <a:noFill/>
+          <a:ln>
+            <a:noFill/>
+          </a:ln>
+        </p:spPr>
+        <p:txBody>
+          <a:bodyPr wrap="square" lIns="0" tIns="0" rIns="0" bIns="0" rtlCol="0" anchor="ctr"/>
+          <a:lstStyle/>
+          <a:p>
+            <a:pPr marL="0" indent="0" algn="ctr">
+              <a:buNone/>
+            </a:pPr>
+            <a:r>
+              <a:rPr lang="en-US" sz="1250" kern="0" dirty="0">
+                <a:solidFill>
+                  <a:srgbClr val="58677A"/>
+                </a:solidFill>
+                <a:latin typeface="Trebuchet MS" pitchFamily="34" charset="0"/>
+                <a:ea typeface="Trebuchet MS" pitchFamily="34" charset="-122"/>
+                <a:cs typeface="Trebuchet MS" pitchFamily="34" charset="-120"/>
+              </a:rPr>
+              <a:t>Collects behavioral rhythm on Windows: mouse movement, typing pace, active windows, and app switching.</a:t>
+            </a:r>
+            <a:endParaRPr lang="en-US" sz="1250" dirty="0"/>
+          </a:p>
+        </p:txBody>
+      </p:sp>
+      <p:sp>
+        <p:nvSpPr>
+          <p:cNvPr id="21" name="Desktop Agent chip C#"/>
+          <p:cNvSpPr/>
+          <p:nvPr/>
+        </p:nvSpPr>
+        <p:spPr>
+          <a:xfrm>
+            <a:off x="851535" y="4448175"/>
+            <a:ext cx="704850" cy="285750"/>
+          </a:xfrm>
+          <a:prstGeom prst="roundRect">
+            <a:avLst/>
+          </a:prstGeom>
+          <a:solidFill>
+            <a:srgbClr val="F3F7F6"/>
+          </a:solidFill>
+          <a:ln w="9525">
+            <a:solidFill>
+              <a:srgbClr val="DCE7E5"/>
+            </a:solidFill>
+          </a:ln>
+        </p:spPr>
+        <p:txBody>
+          <a:bodyPr/>
+          <a:lstStyle/>
+          <a:p>
+            <a:endParaRPr lang="en-US"/>
+          </a:p>
+        </p:txBody>
+      </p:sp>
+      <p:sp>
+        <p:nvSpPr>
+          <p:cNvPr id="22" name="Desktop Agent chip label C#"/>
+          <p:cNvSpPr/>
+          <p:nvPr/>
+        </p:nvSpPr>
+        <p:spPr>
+          <a:xfrm>
+            <a:off x="851535" y="4486275"/>
+            <a:ext cx="704850" cy="209550"/>
+          </a:xfrm>
+          <a:prstGeom prst="rect">
+            <a:avLst/>
+          </a:prstGeom>
+          <a:noFill/>
+          <a:ln>
+            <a:noFill/>
+          </a:ln>
+        </p:spPr>
+        <p:txBody>
+          <a:bodyPr wrap="square" lIns="0" tIns="0" rIns="0" bIns="0" rtlCol="0" anchor="ctr"/>
+          <a:lstStyle/>
+          <a:p>
+            <a:pPr marL="0" indent="0" algn="ctr">
+              <a:buNone/>
+            </a:pPr>
+            <a:r>
+              <a:rPr lang="en-US" sz="1000" b="1" kern="0" dirty="0">
+                <a:solidFill>
+                  <a:srgbClr val="0E8F84"/>
+                </a:solidFill>
+                <a:latin typeface="Trebuchet MS" pitchFamily="34" charset="0"/>
+                <a:ea typeface="Trebuchet MS" pitchFamily="34" charset="-122"/>
+                <a:cs typeface="Trebuchet MS" pitchFamily="34" charset="-120"/>
+              </a:rPr>
+              <a:t>C#</a:t>
+            </a:r>
+            <a:endParaRPr lang="en-US" sz="1000" dirty="0"/>
+          </a:p>
+        </p:txBody>
+      </p:sp>
+      <p:sp>
+        <p:nvSpPr>
+          <p:cNvPr id="23" name="Desktop Agent chip .NET"/>
+          <p:cNvSpPr/>
+          <p:nvPr/>
+        </p:nvSpPr>
+        <p:spPr>
+          <a:xfrm>
+            <a:off x="1613535" y="4448175"/>
+            <a:ext cx="704850" cy="285750"/>
+          </a:xfrm>
+          <a:prstGeom prst="roundRect">
+            <a:avLst/>
+          </a:prstGeom>
+          <a:solidFill>
+            <a:srgbClr val="F3F7F6"/>
+          </a:solidFill>
+          <a:ln w="9525">
+            <a:solidFill>
+              <a:srgbClr val="DCE7E5"/>
+            </a:solidFill>
+          </a:ln>
+        </p:spPr>
+        <p:txBody>
+          <a:bodyPr/>
+          <a:lstStyle/>
+          <a:p>
+            <a:endParaRPr lang="en-US"/>
+          </a:p>
+        </p:txBody>
+      </p:sp>
+      <p:sp>
+        <p:nvSpPr>
+          <p:cNvPr id="24" name="Desktop Agent chip label .NET"/>
+          <p:cNvSpPr/>
+          <p:nvPr/>
+        </p:nvSpPr>
+        <p:spPr>
+          <a:xfrm>
+            <a:off x="1613535" y="4486275"/>
+            <a:ext cx="704850" cy="209550"/>
+          </a:xfrm>
+          <a:prstGeom prst="rect">
+            <a:avLst/>
+          </a:prstGeom>
+          <a:noFill/>
+          <a:ln>
+            <a:noFill/>
+          </a:ln>
+        </p:spPr>
+        <p:txBody>
+          <a:bodyPr wrap="square" lIns="0" tIns="0" rIns="0" bIns="0" rtlCol="0" anchor="ctr"/>
+          <a:lstStyle/>
+          <a:p>
+            <a:pPr marL="0" indent="0" algn="ctr">
+              <a:buNone/>
+            </a:pPr>
+            <a:r>
+              <a:rPr lang="en-US" sz="1000" b="1" kern="0" dirty="0">
+                <a:solidFill>
+                  <a:srgbClr val="0E8F84"/>
+                </a:solidFill>
+                <a:latin typeface="Trebuchet MS" pitchFamily="34" charset="0"/>
+                <a:ea typeface="Trebuchet MS" pitchFamily="34" charset="-122"/>
+                <a:cs typeface="Trebuchet MS" pitchFamily="34" charset="-120"/>
+              </a:rPr>
+              <a:t>.NET</a:t>
+            </a:r>
+            <a:endParaRPr lang="en-US" sz="1000" dirty="0"/>
+          </a:p>
+        </p:txBody>
+      </p:sp>
+      <p:sp>
+        <p:nvSpPr>
+          <p:cNvPr id="25" name="Desktop Agent chip Windows"/>
+          <p:cNvSpPr/>
+          <p:nvPr/>
+        </p:nvSpPr>
+        <p:spPr>
+          <a:xfrm>
+            <a:off x="2375535" y="4448175"/>
+            <a:ext cx="704850" cy="285750"/>
+          </a:xfrm>
+          <a:prstGeom prst="roundRect">
+            <a:avLst/>
+          </a:prstGeom>
+          <a:solidFill>
+            <a:srgbClr val="F3F7F6"/>
+          </a:solidFill>
+          <a:ln w="9525">
+            <a:solidFill>
+              <a:srgbClr val="DCE7E5"/>
+            </a:solidFill>
+          </a:ln>
+        </p:spPr>
+        <p:txBody>
+          <a:bodyPr/>
+          <a:lstStyle/>
+          <a:p>
+            <a:endParaRPr lang="en-US"/>
+          </a:p>
+        </p:txBody>
+      </p:sp>
+      <p:sp>
+        <p:nvSpPr>
+          <p:cNvPr id="26" name="Desktop Agent chip label Windows"/>
+          <p:cNvSpPr/>
+          <p:nvPr/>
+        </p:nvSpPr>
+        <p:spPr>
+          <a:xfrm>
+            <a:off x="2375535" y="4486275"/>
+            <a:ext cx="704850" cy="209550"/>
+          </a:xfrm>
+          <a:prstGeom prst="rect">
+            <a:avLst/>
+          </a:prstGeom>
+          <a:noFill/>
+          <a:ln>
+            <a:noFill/>
+          </a:ln>
+        </p:spPr>
+        <p:txBody>
+          <a:bodyPr wrap="square" lIns="0" tIns="0" rIns="0" bIns="0" rtlCol="0" anchor="ctr"/>
+          <a:lstStyle/>
+          <a:p>
+            <a:pPr marL="0" indent="0" algn="ctr">
+              <a:buNone/>
+            </a:pPr>
+            <a:r>
+              <a:rPr lang="en-US" sz="1000" b="1" kern="0" dirty="0">
+                <a:solidFill>
+                  <a:srgbClr val="0E8F84"/>
+                </a:solidFill>
+                <a:latin typeface="Trebuchet MS" pitchFamily="34" charset="0"/>
+                <a:ea typeface="Trebuchet MS" pitchFamily="34" charset="-122"/>
+                <a:cs typeface="Trebuchet MS" pitchFamily="34" charset="-120"/>
+              </a:rPr>
+              <a:t>Windows</a:t>
+            </a:r>
+            <a:endParaRPr lang="en-US" sz="1000" dirty="0"/>
+          </a:p>
+        </p:txBody>
+      </p:sp>
+      <p:sp>
+        <p:nvSpPr>
+          <p:cNvPr id="27" name="KungFlow Server card"/>
+          <p:cNvSpPr/>
+          <p:nvPr/>
+        </p:nvSpPr>
+        <p:spPr>
+          <a:xfrm>
+            <a:off x="4667250" y="2047875"/>
+            <a:ext cx="2857500" cy="3000375"/>
+          </a:xfrm>
+          <a:prstGeom prst="roundRect">
+            <a:avLst/>
+          </a:prstGeom>
+          <a:solidFill>
+            <a:srgbClr val="FFFFFF"/>
+          </a:solidFill>
+          <a:ln w="9525">
+            <a:solidFill>
+              <a:srgbClr val="D7E2E0"/>
+            </a:solidFill>
+          </a:ln>
+        </p:spPr>
+        <p:txBody>
+          <a:bodyPr/>
+          <a:lstStyle/>
+          <a:p>
+            <a:endParaRPr lang="en-US"/>
+          </a:p>
+        </p:txBody>
+      </p:sp>
+      <p:sp>
+        <p:nvSpPr>
+          <p:cNvPr id="28" name="KungFlow Server icon box"/>
+          <p:cNvSpPr/>
+          <p:nvPr/>
+        </p:nvSpPr>
+        <p:spPr>
+          <a:xfrm>
+            <a:off x="4933950" y="2343150"/>
+            <a:ext cx="685800" cy="685800"/>
+          </a:xfrm>
+          <a:prstGeom prst="roundRect">
+            <a:avLst/>
+          </a:prstGeom>
+          <a:solidFill>
+            <a:srgbClr val="EDF4F3"/>
+          </a:solidFill>
+          <a:ln w="9525">
+            <a:solidFill>
+              <a:srgbClr val="CFE0DD"/>
+            </a:solidFill>
+          </a:ln>
+        </p:spPr>
+        <p:txBody>
+          <a:bodyPr/>
+          <a:lstStyle/>
+          <a:p>
+            <a:endParaRPr lang="en-US"/>
+          </a:p>
+        </p:txBody>
+      </p:sp>
+      <p:pic>
+        <p:nvPicPr>
+          <p:cNvPr id="29" name="KungFlow Server icon"/>
+          <p:cNvPicPr>
+            <a:picLocks noChangeAspect="1"/>
+          </p:cNvPicPr>
+          <p:nvPr/>
+        </p:nvPicPr>
+        <p:blipFill>
+          <a:blip r:embed="rId5"/>
+          <a:stretch>
+            <a:fillRect/>
+          </a:stretch>
+        </p:blipFill>
+        <p:spPr>
+          <a:xfrm>
+            <a:off x="5095875" y="2505075"/>
+            <a:ext cx="361950" cy="361950"/>
+          </a:xfrm>
+          <a:prstGeom prst="rect">
+            <a:avLst/>
+          </a:prstGeom>
+          <a:ln>
+            <a:noFill/>
+          </a:ln>
+        </p:spPr>
+      </p:pic>
+      <p:sp>
+        <p:nvSpPr>
+          <p:cNvPr id="30" name="KungFlow Server title"/>
+          <p:cNvSpPr/>
+          <p:nvPr/>
+        </p:nvSpPr>
+        <p:spPr>
+          <a:xfrm>
+            <a:off x="5695950" y="2409825"/>
+            <a:ext cx="1581150" cy="419100"/>
+          </a:xfrm>
+          <a:prstGeom prst="rect">
+            <a:avLst/>
+          </a:prstGeom>
+          <a:noFill/>
+          <a:ln>
+            <a:noFill/>
+          </a:ln>
+        </p:spPr>
+        <p:txBody>
+          <a:bodyPr wrap="square" lIns="0" tIns="0" rIns="0" bIns="0" rtlCol="0" anchor="ctr"/>
+          <a:lstStyle/>
+          <a:p>
+            <a:pPr marL="0" indent="0" algn="l">
+              <a:buNone/>
+            </a:pPr>
+            <a:r>
+              <a:rPr lang="en-US" sz="1850" b="1" kern="0" dirty="0">
+                <a:solidFill>
+                  <a:srgbClr val="122033"/>
+                </a:solidFill>
+                <a:latin typeface="Trebuchet MS" pitchFamily="34" charset="0"/>
+                <a:ea typeface="Trebuchet MS" pitchFamily="34" charset="-122"/>
+                <a:cs typeface="Trebuchet MS" pitchFamily="34" charset="-120"/>
+              </a:rPr>
+              <a:t>KungFlow Server</a:t>
+            </a:r>
+            <a:endParaRPr lang="en-US" sz="1850" dirty="0"/>
+          </a:p>
+        </p:txBody>
+      </p:sp>
+      <p:sp>
+        <p:nvSpPr>
+          <p:cNvPr id="31" name="KungFlow Server accent"/>
+          <p:cNvSpPr/>
+          <p:nvPr/>
+        </p:nvSpPr>
+        <p:spPr>
+          <a:xfrm>
+            <a:off x="4667250" y="2047875"/>
+            <a:ext cx="2857500" cy="66675"/>
+          </a:xfrm>
+          <a:prstGeom prst="rect">
+            <a:avLst/>
+          </a:prstGeom>
+          <a:solidFill>
+            <a:srgbClr val="3478E5"/>
+          </a:solidFill>
+          <a:ln>
+            <a:noFill/>
+          </a:ln>
+        </p:spPr>
+        <p:txBody>
+          <a:bodyPr/>
+          <a:lstStyle/>
+          <a:p>
+            <a:endParaRPr lang="en-US"/>
+          </a:p>
+        </p:txBody>
+      </p:sp>
+      <p:sp>
+        <p:nvSpPr>
+          <p:cNvPr id="32" name="KungFlow Server body"/>
+          <p:cNvSpPr/>
+          <p:nvPr/>
+        </p:nvSpPr>
+        <p:spPr>
+          <a:xfrm>
+            <a:off x="4933950" y="3267075"/>
+            <a:ext cx="2324100" cy="1000125"/>
+          </a:xfrm>
+          <a:prstGeom prst="rect">
+            <a:avLst/>
+          </a:prstGeom>
+          <a:noFill/>
+          <a:ln>
+            <a:noFill/>
+          </a:ln>
+        </p:spPr>
+        <p:txBody>
+          <a:bodyPr wrap="square" lIns="0" tIns="0" rIns="0" bIns="0" rtlCol="0" anchor="ctr"/>
+          <a:lstStyle/>
+          <a:p>
+            <a:pPr marL="0" indent="0" algn="ctr">
+              <a:buNone/>
+            </a:pPr>
+            <a:r>
+              <a:rPr lang="en-US" sz="1250" kern="0" dirty="0">
+                <a:solidFill>
+                  <a:srgbClr val="58677A"/>
+                </a:solidFill>
+                <a:latin typeface="Trebuchet MS" pitchFamily="34" charset="0"/>
+                <a:ea typeface="Trebuchet MS" pitchFamily="34" charset="-122"/>
+                <a:cs typeface="Trebuchet MS" pitchFamily="34" charset="-120"/>
+              </a:rPr>
+              <a:t>Receives activity samples, authenticates users, scores current load against the personal baseline, and returns a protection decision.</a:t>
+            </a:r>
+            <a:endParaRPr lang="en-US" sz="1250" dirty="0"/>
+          </a:p>
+        </p:txBody>
+      </p:sp>
+      <p:sp>
+        <p:nvSpPr>
+          <p:cNvPr id="33" name="KungFlow Server chip Node.js"/>
+          <p:cNvSpPr/>
+          <p:nvPr/>
+        </p:nvSpPr>
+        <p:spPr>
+          <a:xfrm>
+            <a:off x="4924425" y="4448175"/>
+            <a:ext cx="704850" cy="285750"/>
+          </a:xfrm>
+          <a:prstGeom prst="roundRect">
+            <a:avLst/>
+          </a:prstGeom>
+          <a:solidFill>
+            <a:srgbClr val="F3F7F6"/>
+          </a:solidFill>
+          <a:ln w="9525">
+            <a:solidFill>
+              <a:srgbClr val="DCE7E5"/>
+            </a:solidFill>
+          </a:ln>
+        </p:spPr>
+        <p:txBody>
+          <a:bodyPr/>
+          <a:lstStyle/>
+          <a:p>
+            <a:endParaRPr lang="en-US"/>
+          </a:p>
+        </p:txBody>
+      </p:sp>
+      <p:sp>
+        <p:nvSpPr>
+          <p:cNvPr id="34" name="KungFlow Server chip label Node.js"/>
+          <p:cNvSpPr/>
+          <p:nvPr/>
+        </p:nvSpPr>
+        <p:spPr>
+          <a:xfrm>
+            <a:off x="4924425" y="4486275"/>
+            <a:ext cx="704850" cy="209550"/>
+          </a:xfrm>
+          <a:prstGeom prst="rect">
+            <a:avLst/>
+          </a:prstGeom>
+          <a:noFill/>
+          <a:ln>
+            <a:noFill/>
+          </a:ln>
+        </p:spPr>
+        <p:txBody>
+          <a:bodyPr wrap="square" lIns="0" tIns="0" rIns="0" bIns="0" rtlCol="0" anchor="ctr"/>
+          <a:lstStyle/>
+          <a:p>
+            <a:pPr marL="0" indent="0" algn="ctr">
+              <a:buNone/>
+            </a:pPr>
+            <a:r>
+              <a:rPr lang="en-US" sz="1000" b="1" kern="0" dirty="0">
+                <a:solidFill>
+                  <a:srgbClr val="3478E5"/>
+                </a:solidFill>
+                <a:latin typeface="Trebuchet MS" pitchFamily="34" charset="0"/>
+                <a:ea typeface="Trebuchet MS" pitchFamily="34" charset="-122"/>
+                <a:cs typeface="Trebuchet MS" pitchFamily="34" charset="-120"/>
+              </a:rPr>
+              <a:t>Node.js</a:t>
+            </a:r>
+            <a:endParaRPr lang="en-US" sz="1000" dirty="0"/>
+          </a:p>
+        </p:txBody>
+      </p:sp>
+      <p:sp>
+        <p:nvSpPr>
+          <p:cNvPr id="35" name="KungFlow Server chip Express"/>
+          <p:cNvSpPr/>
+          <p:nvPr/>
+        </p:nvSpPr>
+        <p:spPr>
+          <a:xfrm>
+            <a:off x="5686425" y="4448175"/>
+            <a:ext cx="704850" cy="285750"/>
+          </a:xfrm>
+          <a:prstGeom prst="roundRect">
+            <a:avLst/>
+          </a:prstGeom>
+          <a:solidFill>
+            <a:srgbClr val="F3F7F6"/>
+          </a:solidFill>
+          <a:ln w="9525">
+            <a:solidFill>
+              <a:srgbClr val="DCE7E5"/>
+            </a:solidFill>
+          </a:ln>
+        </p:spPr>
+        <p:txBody>
+          <a:bodyPr/>
+          <a:lstStyle/>
+          <a:p>
+            <a:endParaRPr lang="en-US"/>
+          </a:p>
+        </p:txBody>
+      </p:sp>
+      <p:sp>
+        <p:nvSpPr>
+          <p:cNvPr id="36" name="KungFlow Server chip label Express"/>
+          <p:cNvSpPr/>
+          <p:nvPr/>
+        </p:nvSpPr>
+        <p:spPr>
+          <a:xfrm>
+            <a:off x="5686425" y="4486275"/>
+            <a:ext cx="704850" cy="209550"/>
+          </a:xfrm>
+          <a:prstGeom prst="rect">
+            <a:avLst/>
+          </a:prstGeom>
+          <a:noFill/>
+          <a:ln>
+            <a:noFill/>
+          </a:ln>
+        </p:spPr>
+        <p:txBody>
+          <a:bodyPr wrap="square" lIns="0" tIns="0" rIns="0" bIns="0" rtlCol="0" anchor="ctr"/>
+          <a:lstStyle/>
+          <a:p>
+            <a:pPr marL="0" indent="0" algn="ctr">
+              <a:buNone/>
+            </a:pPr>
+            <a:r>
+              <a:rPr lang="en-US" sz="1000" b="1" kern="0" dirty="0">
+                <a:solidFill>
+                  <a:srgbClr val="3478E5"/>
+                </a:solidFill>
+                <a:latin typeface="Trebuchet MS" pitchFamily="34" charset="0"/>
+                <a:ea typeface="Trebuchet MS" pitchFamily="34" charset="-122"/>
+                <a:cs typeface="Trebuchet MS" pitchFamily="34" charset="-120"/>
+              </a:rPr>
+              <a:t>Express</a:t>
+            </a:r>
+            <a:endParaRPr lang="en-US" sz="1000" dirty="0"/>
+          </a:p>
+        </p:txBody>
+      </p:sp>
+      <p:sp>
+        <p:nvSpPr>
+          <p:cNvPr id="37" name="KungFlow Server chip API"/>
+          <p:cNvSpPr/>
+          <p:nvPr/>
+        </p:nvSpPr>
+        <p:spPr>
+          <a:xfrm>
+            <a:off x="6448425" y="4448175"/>
+            <a:ext cx="704850" cy="285750"/>
+          </a:xfrm>
+          <a:prstGeom prst="roundRect">
+            <a:avLst/>
+          </a:prstGeom>
+          <a:solidFill>
+            <a:srgbClr val="F3F7F6"/>
+          </a:solidFill>
+          <a:ln w="9525">
+            <a:solidFill>
+              <a:srgbClr val="DCE7E5"/>
+            </a:solidFill>
+          </a:ln>
+        </p:spPr>
+        <p:txBody>
+          <a:bodyPr/>
+          <a:lstStyle/>
+          <a:p>
+            <a:endParaRPr lang="en-US"/>
+          </a:p>
+        </p:txBody>
+      </p:sp>
+      <p:sp>
+        <p:nvSpPr>
+          <p:cNvPr id="38" name="KungFlow Server chip label API"/>
+          <p:cNvSpPr/>
+          <p:nvPr/>
+        </p:nvSpPr>
+        <p:spPr>
+          <a:xfrm>
+            <a:off x="6448425" y="4486275"/>
+            <a:ext cx="704850" cy="209550"/>
+          </a:xfrm>
+          <a:prstGeom prst="rect">
+            <a:avLst/>
+          </a:prstGeom>
+          <a:noFill/>
+          <a:ln>
+            <a:noFill/>
+          </a:ln>
+        </p:spPr>
+        <p:txBody>
+          <a:bodyPr wrap="square" lIns="0" tIns="0" rIns="0" bIns="0" rtlCol="0" anchor="ctr"/>
+          <a:lstStyle/>
+          <a:p>
+            <a:pPr marL="0" indent="0" algn="ctr">
+              <a:buNone/>
+            </a:pPr>
+            <a:r>
+              <a:rPr lang="en-US" sz="1000" b="1" kern="0" dirty="0">
+                <a:solidFill>
+                  <a:srgbClr val="3478E5"/>
+                </a:solidFill>
+                <a:latin typeface="Trebuchet MS" pitchFamily="34" charset="0"/>
+                <a:ea typeface="Trebuchet MS" pitchFamily="34" charset="-122"/>
+                <a:cs typeface="Trebuchet MS" pitchFamily="34" charset="-120"/>
+              </a:rPr>
+              <a:t>API</a:t>
+            </a:r>
+            <a:endParaRPr lang="en-US" sz="1000" dirty="0"/>
+          </a:p>
+        </p:txBody>
+      </p:sp>
+      <p:sp>
+        <p:nvSpPr>
+          <p:cNvPr id="39" name="SQL Database card"/>
+          <p:cNvSpPr/>
+          <p:nvPr/>
+        </p:nvSpPr>
+        <p:spPr>
+          <a:xfrm>
+            <a:off x="8740140" y="2047875"/>
+            <a:ext cx="2857500" cy="3000375"/>
+          </a:xfrm>
+          <a:prstGeom prst="roundRect">
+            <a:avLst/>
+          </a:prstGeom>
+          <a:solidFill>
+            <a:srgbClr val="FFFFFF"/>
+          </a:solidFill>
+          <a:ln w="9525">
+            <a:solidFill>
+              <a:srgbClr val="D7E2E0"/>
+            </a:solidFill>
+          </a:ln>
+        </p:spPr>
+        <p:txBody>
+          <a:bodyPr/>
+          <a:lstStyle/>
+          <a:p>
+            <a:endParaRPr lang="en-US"/>
+          </a:p>
+        </p:txBody>
+      </p:sp>
+      <p:sp>
+        <p:nvSpPr>
+          <p:cNvPr id="40" name="SQL Database icon box"/>
+          <p:cNvSpPr/>
+          <p:nvPr/>
+        </p:nvSpPr>
+        <p:spPr>
+          <a:xfrm>
+            <a:off x="9006840" y="2343150"/>
+            <a:ext cx="685800" cy="685800"/>
+          </a:xfrm>
+          <a:prstGeom prst="roundRect">
+            <a:avLst/>
+          </a:prstGeom>
+          <a:solidFill>
+            <a:srgbClr val="EDF4F3"/>
+          </a:solidFill>
+          <a:ln w="9525">
+            <a:solidFill>
+              <a:srgbClr val="CFE0DD"/>
+            </a:solidFill>
+          </a:ln>
+        </p:spPr>
+        <p:txBody>
+          <a:bodyPr/>
+          <a:lstStyle/>
+          <a:p>
+            <a:endParaRPr lang="en-US"/>
+          </a:p>
+        </p:txBody>
+      </p:sp>
+      <p:pic>
+        <p:nvPicPr>
+          <p:cNvPr id="41" name="SQL Database icon"/>
+          <p:cNvPicPr>
+            <a:picLocks noChangeAspect="1"/>
+          </p:cNvPicPr>
+          <p:nvPr/>
+        </p:nvPicPr>
+        <p:blipFill>
+          <a:blip r:embed="rId6"/>
+          <a:stretch>
+            <a:fillRect/>
+          </a:stretch>
+        </p:blipFill>
+        <p:spPr>
+          <a:xfrm>
+            <a:off x="9168765" y="2505075"/>
+            <a:ext cx="361950" cy="361950"/>
+          </a:xfrm>
+          <a:prstGeom prst="rect">
+            <a:avLst/>
+          </a:prstGeom>
+          <a:ln>
+            <a:noFill/>
+          </a:ln>
+        </p:spPr>
+      </p:pic>
+      <p:sp>
+        <p:nvSpPr>
+          <p:cNvPr id="42" name="SQL Database title"/>
+          <p:cNvSpPr/>
+          <p:nvPr/>
+        </p:nvSpPr>
+        <p:spPr>
+          <a:xfrm>
+            <a:off x="9768840" y="2409825"/>
+            <a:ext cx="1581150" cy="419100"/>
+          </a:xfrm>
+          <a:prstGeom prst="rect">
+            <a:avLst/>
+          </a:prstGeom>
+          <a:noFill/>
+          <a:ln>
+            <a:noFill/>
+          </a:ln>
+        </p:spPr>
+        <p:txBody>
+          <a:bodyPr wrap="square" lIns="0" tIns="0" rIns="0" bIns="0" rtlCol="0" anchor="ctr"/>
+          <a:lstStyle/>
+          <a:p>
+            <a:pPr marL="0" indent="0" algn="l">
+              <a:buNone/>
+            </a:pPr>
+            <a:r>
+              <a:rPr lang="en-US" sz="1850" b="1" kern="0" dirty="0">
+                <a:solidFill>
+                  <a:srgbClr val="122033"/>
+                </a:solidFill>
+                <a:latin typeface="Trebuchet MS" pitchFamily="34" charset="0"/>
+                <a:ea typeface="Trebuchet MS" pitchFamily="34" charset="-122"/>
+                <a:cs typeface="Trebuchet MS" pitchFamily="34" charset="-120"/>
+              </a:rPr>
+              <a:t>SQL Database</a:t>
+            </a:r>
+            <a:endParaRPr lang="en-US" sz="1850" dirty="0"/>
+          </a:p>
+        </p:txBody>
+      </p:sp>
+      <p:sp>
+        <p:nvSpPr>
+          <p:cNvPr id="43" name="SQL Database accent"/>
+          <p:cNvSpPr/>
+          <p:nvPr/>
+        </p:nvSpPr>
+        <p:spPr>
+          <a:xfrm>
+            <a:off x="8740140" y="2047875"/>
+            <a:ext cx="2857500" cy="66675"/>
+          </a:xfrm>
+          <a:prstGeom prst="rect">
+            <a:avLst/>
+          </a:prstGeom>
+          <a:solidFill>
+            <a:srgbClr val="7B61D1"/>
+          </a:solidFill>
+          <a:ln>
+            <a:noFill/>
+          </a:ln>
+        </p:spPr>
+        <p:txBody>
+          <a:bodyPr/>
+          <a:lstStyle/>
+          <a:p>
+            <a:endParaRPr lang="en-US"/>
+          </a:p>
+        </p:txBody>
+      </p:sp>
+      <p:sp>
+        <p:nvSpPr>
+          <p:cNvPr id="44" name="SQL Database body"/>
+          <p:cNvSpPr/>
+          <p:nvPr/>
+        </p:nvSpPr>
+        <p:spPr>
+          <a:xfrm>
+            <a:off x="9006840" y="3267075"/>
+            <a:ext cx="2324100" cy="1000125"/>
+          </a:xfrm>
+          <a:prstGeom prst="rect">
+            <a:avLst/>
+          </a:prstGeom>
+          <a:noFill/>
+          <a:ln>
+            <a:noFill/>
+          </a:ln>
+        </p:spPr>
+        <p:txBody>
+          <a:bodyPr wrap="square" lIns="0" tIns="0" rIns="0" bIns="0" rtlCol="0" anchor="ctr"/>
+          <a:lstStyle/>
+          <a:p>
+            <a:pPr marL="0" indent="0" algn="ctr">
+              <a:buNone/>
+            </a:pPr>
+            <a:r>
+              <a:rPr lang="en-US" sz="1250" kern="0" dirty="0">
+                <a:solidFill>
+                  <a:srgbClr val="58677A"/>
+                </a:solidFill>
+                <a:latin typeface="Trebuchet MS" pitchFamily="34" charset="0"/>
+                <a:ea typeface="Trebuchet MS" pitchFamily="34" charset="-122"/>
+                <a:cs typeface="Trebuchet MS" pitchFamily="34" charset="-120"/>
+              </a:rPr>
+              <a:t>Stores users, sessions, behavioral samples, baseline state, and firewall activation events.</a:t>
+            </a:r>
+            <a:endParaRPr lang="en-US" sz="1250" dirty="0"/>
+          </a:p>
+        </p:txBody>
+      </p:sp>
+      <p:sp>
+        <p:nvSpPr>
+          <p:cNvPr id="45" name="SQL Database chip Users"/>
+          <p:cNvSpPr/>
+          <p:nvPr/>
+        </p:nvSpPr>
+        <p:spPr>
+          <a:xfrm>
+            <a:off x="8997315" y="4448175"/>
+            <a:ext cx="704850" cy="285750"/>
+          </a:xfrm>
+          <a:prstGeom prst="roundRect">
+            <a:avLst/>
+          </a:prstGeom>
+          <a:solidFill>
+            <a:srgbClr val="F3F7F6"/>
+          </a:solidFill>
+          <a:ln w="9525">
+            <a:solidFill>
+              <a:srgbClr val="DCE7E5"/>
+            </a:solidFill>
+          </a:ln>
+        </p:spPr>
+        <p:txBody>
+          <a:bodyPr/>
+          <a:lstStyle/>
+          <a:p>
+            <a:endParaRPr lang="en-US"/>
+          </a:p>
+        </p:txBody>
+      </p:sp>
+      <p:sp>
+        <p:nvSpPr>
+          <p:cNvPr id="46" name="SQL Database chip label Users"/>
+          <p:cNvSpPr/>
+          <p:nvPr/>
+        </p:nvSpPr>
+        <p:spPr>
+          <a:xfrm>
+            <a:off x="8997315" y="4486275"/>
+            <a:ext cx="704850" cy="209550"/>
+          </a:xfrm>
+          <a:prstGeom prst="rect">
+            <a:avLst/>
+          </a:prstGeom>
+          <a:noFill/>
+          <a:ln>
+            <a:noFill/>
+          </a:ln>
+        </p:spPr>
+        <p:txBody>
+          <a:bodyPr wrap="square" lIns="0" tIns="0" rIns="0" bIns="0" rtlCol="0" anchor="ctr"/>
+          <a:lstStyle/>
+          <a:p>
+            <a:pPr marL="0" indent="0" algn="ctr">
+              <a:buNone/>
+            </a:pPr>
+            <a:r>
+              <a:rPr lang="en-US" sz="1000" b="1" kern="0" dirty="0">
+                <a:solidFill>
+                  <a:srgbClr val="7B61D1"/>
+                </a:solidFill>
+                <a:latin typeface="Trebuchet MS" pitchFamily="34" charset="0"/>
+                <a:ea typeface="Trebuchet MS" pitchFamily="34" charset="-122"/>
+                <a:cs typeface="Trebuchet MS" pitchFamily="34" charset="-120"/>
+              </a:rPr>
+              <a:t>Users</a:t>
+            </a:r>
+            <a:endParaRPr lang="en-US" sz="1000" dirty="0"/>
+          </a:p>
+        </p:txBody>
+      </p:sp>
+      <p:sp>
+        <p:nvSpPr>
+          <p:cNvPr id="47" name="SQL Database chip Metrics"/>
+          <p:cNvSpPr/>
+          <p:nvPr/>
+        </p:nvSpPr>
+        <p:spPr>
+          <a:xfrm>
+            <a:off x="9759315" y="4448175"/>
+            <a:ext cx="704850" cy="285750"/>
+          </a:xfrm>
+          <a:prstGeom prst="roundRect">
+            <a:avLst/>
+          </a:prstGeom>
+          <a:solidFill>
+            <a:srgbClr val="F3F7F6"/>
+          </a:solidFill>
+          <a:ln w="9525">
+            <a:solidFill>
+              <a:srgbClr val="DCE7E5"/>
+            </a:solidFill>
+          </a:ln>
+        </p:spPr>
+        <p:txBody>
+          <a:bodyPr/>
+          <a:lstStyle/>
+          <a:p>
+            <a:endParaRPr lang="en-US"/>
+          </a:p>
+        </p:txBody>
+      </p:sp>
+      <p:sp>
+        <p:nvSpPr>
+          <p:cNvPr id="48" name="SQL Database chip label Metrics"/>
+          <p:cNvSpPr/>
+          <p:nvPr/>
+        </p:nvSpPr>
+        <p:spPr>
+          <a:xfrm>
+            <a:off x="9759315" y="4486275"/>
+            <a:ext cx="704850" cy="209550"/>
+          </a:xfrm>
+          <a:prstGeom prst="rect">
+            <a:avLst/>
+          </a:prstGeom>
+          <a:noFill/>
+          <a:ln>
+            <a:noFill/>
+          </a:ln>
+        </p:spPr>
+        <p:txBody>
+          <a:bodyPr wrap="square" lIns="0" tIns="0" rIns="0" bIns="0" rtlCol="0" anchor="ctr"/>
+          <a:lstStyle/>
+          <a:p>
+            <a:pPr marL="0" indent="0" algn="ctr">
+              <a:buNone/>
+            </a:pPr>
+            <a:r>
+              <a:rPr lang="en-US" sz="1000" b="1" kern="0" dirty="0">
+                <a:solidFill>
+                  <a:srgbClr val="7B61D1"/>
+                </a:solidFill>
+                <a:latin typeface="Trebuchet MS" pitchFamily="34" charset="0"/>
+                <a:ea typeface="Trebuchet MS" pitchFamily="34" charset="-122"/>
+                <a:cs typeface="Trebuchet MS" pitchFamily="34" charset="-120"/>
+              </a:rPr>
+              <a:t>Metrics</a:t>
+            </a:r>
+            <a:endParaRPr lang="en-US" sz="1000" dirty="0"/>
+          </a:p>
+        </p:txBody>
+      </p:sp>
+      <p:sp>
+        <p:nvSpPr>
+          <p:cNvPr id="49" name="SQL Database chip Baseline"/>
+          <p:cNvSpPr/>
+          <p:nvPr/>
+        </p:nvSpPr>
+        <p:spPr>
+          <a:xfrm>
+            <a:off x="10521315" y="4448175"/>
+            <a:ext cx="704850" cy="285750"/>
+          </a:xfrm>
+          <a:prstGeom prst="roundRect">
+            <a:avLst/>
+          </a:prstGeom>
+          <a:solidFill>
+            <a:srgbClr val="F3F7F6"/>
+          </a:solidFill>
+          <a:ln w="9525">
+            <a:solidFill>
+              <a:srgbClr val="DCE7E5"/>
+            </a:solidFill>
+          </a:ln>
+        </p:spPr>
+        <p:txBody>
+          <a:bodyPr/>
+          <a:lstStyle/>
+          <a:p>
+            <a:endParaRPr lang="en-US"/>
+          </a:p>
+        </p:txBody>
+      </p:sp>
+      <p:sp>
+        <p:nvSpPr>
+          <p:cNvPr id="50" name="SQL Database chip label Baseline"/>
+          <p:cNvSpPr/>
+          <p:nvPr/>
+        </p:nvSpPr>
+        <p:spPr>
+          <a:xfrm>
+            <a:off x="10521315" y="4486275"/>
+            <a:ext cx="704850" cy="209550"/>
+          </a:xfrm>
+          <a:prstGeom prst="rect">
+            <a:avLst/>
+          </a:prstGeom>
+          <a:noFill/>
+          <a:ln>
+            <a:noFill/>
+          </a:ln>
+        </p:spPr>
+        <p:txBody>
+          <a:bodyPr wrap="square" lIns="0" tIns="0" rIns="0" bIns="0" rtlCol="0" anchor="ctr"/>
+          <a:lstStyle/>
+          <a:p>
+            <a:pPr marL="0" indent="0" algn="ctr">
+              <a:buNone/>
+            </a:pPr>
+            <a:r>
+              <a:rPr lang="en-US" sz="1000" b="1" kern="0" dirty="0">
+                <a:solidFill>
+                  <a:srgbClr val="7B61D1"/>
+                </a:solidFill>
+                <a:latin typeface="Trebuchet MS" pitchFamily="34" charset="0"/>
+                <a:ea typeface="Trebuchet MS" pitchFamily="34" charset="-122"/>
+                <a:cs typeface="Trebuchet MS" pitchFamily="34" charset="-120"/>
+              </a:rPr>
+              <a:t>Baseline</a:t>
+            </a:r>
+            <a:endParaRPr lang="en-US" sz="1000" dirty="0"/>
+          </a:p>
+        </p:txBody>
+      </p:sp>
+      <p:sp>
+        <p:nvSpPr>
+          <p:cNvPr id="51" name="Architecture summary panel"/>
+          <p:cNvSpPr/>
+          <p:nvPr/>
+        </p:nvSpPr>
+        <p:spPr>
+          <a:xfrm>
+            <a:off x="594360" y="5429250"/>
+            <a:ext cx="11000232" cy="590550"/>
+          </a:xfrm>
+          <a:prstGeom prst="roundRect">
+            <a:avLst/>
+          </a:prstGeom>
+          <a:solidFill>
+            <a:srgbClr val="EDF7F6"/>
+          </a:solidFill>
+          <a:ln w="9525">
+            <a:solidFill>
+              <a:srgbClr val="C9DEDA"/>
+            </a:solidFill>
+          </a:ln>
+        </p:spPr>
+        <p:txBody>
+          <a:bodyPr/>
+          <a:lstStyle/>
+          <a:p>
+            <a:endParaRPr lang="en-US"/>
+          </a:p>
+        </p:txBody>
+      </p:sp>
+      <p:sp>
+        <p:nvSpPr>
+          <p:cNvPr id="52" name="Architecture summary text"/>
+          <p:cNvSpPr/>
+          <p:nvPr/>
+        </p:nvSpPr>
+        <p:spPr>
+          <a:xfrm>
+            <a:off x="952500" y="5524500"/>
+            <a:ext cx="10287000" cy="400050"/>
+          </a:xfrm>
+          <a:prstGeom prst="rect">
+            <a:avLst/>
+          </a:prstGeom>
+          <a:noFill/>
+          <a:ln>
+            <a:noFill/>
+          </a:ln>
+        </p:spPr>
+        <p:txBody>
+          <a:bodyPr wrap="square" lIns="0" tIns="0" rIns="0" bIns="0" rtlCol="0" anchor="ctr"/>
+          <a:lstStyle/>
+          <a:p>
+            <a:pPr marL="0" indent="0" algn="ctr">
+              <a:buNone/>
+            </a:pPr>
+            <a:r>
+              <a:rPr lang="en-US" sz="1500" b="1" kern="0" dirty="0">
+                <a:solidFill>
+                  <a:srgbClr val="122033"/>
+                </a:solidFill>
+                <a:latin typeface="Trebuchet MS" pitchFamily="34" charset="0"/>
+                <a:ea typeface="Trebuchet MS" pitchFamily="34" charset="-122"/>
+                <a:cs typeface="Trebuchet MS" pitchFamily="34" charset="-120"/>
+              </a:rPr>
+              <a:t>The agent never sends content. It sends metadata samples, the server computes state, and the firewall decision returns to the desktop in real time.</a:t>
+            </a:r>
+            <a:endParaRPr lang="en-US" sz="1500" dirty="0"/>
+          </a:p>
+        </p:txBody>
+      </p:sp>
+    </p:spTree>
+  </p:cSld>
+  <p:clrMapOvr>
+    <a:masterClrMapping/>
+  </p:clrMapOvr>
+</p:sld>
+</file>
+
 <file path=ppt/slides/slide2.xml><?xml version="1.0" encoding="utf-8"?>
 <p:sld xmlns:a="http://schemas.openxmlformats.org/drawingml/2006/main" xmlns:r="http://schemas.openxmlformats.org/officeDocument/2006/relationships" xmlns:p="http://schemas.openxmlformats.org/presentationml/2006/main">
   <p:cSld name="Slide 2">
@@ -17062,7 +18877,7 @@
                 <a:ea typeface="Calibri" pitchFamily="34" charset="-122"/>
                 <a:cs typeface="Calibri" pitchFamily="34" charset="-120"/>
               </a:rPr>
-              <a:t>9</a:t>
+              <a:t>10</a:t>
             </a:r>
             <a:endParaRPr lang="en-US" sz="1200" dirty="0"/>
           </a:p>
@@ -18045,7 +19860,7 @@
                 <a:ea typeface="Calibri" pitchFamily="34" charset="-122"/>
                 <a:cs typeface="Calibri" pitchFamily="34" charset="-120"/>
               </a:rPr>
-              <a:t>10</a:t>
+              <a:t>11</a:t>
             </a:r>
             <a:endParaRPr lang="en-US" sz="1200" dirty="0"/>
           </a:p>

</xml_diff>